<commit_message>
feat: 8 optimization items - T0.5 normalizer, threshold sweep, rocBLAS warmup, prefill/decode split, cache hit/miss, HSA fallback, split-mode A/B, orchestrator batch queue
</commit_message>
<xml_diff>
--- a/enterprise_presentation/Warden_Enterprise_Deck.pptx
+++ b/enterprise_presentation/Warden_Enterprise_Deck.pptx
@@ -5,18 +5,18 @@
     <p:sldMasterId id="2147483648" r:id="rId1"/>
   </p:sldMasterIdLst>
   <p:sldIdLst>
-    <p:sldId id="256" r:id="rId7"/>
-    <p:sldId id="257" r:id="rId8"/>
-    <p:sldId id="258" r:id="rId9"/>
-    <p:sldId id="259" r:id="rId10"/>
-    <p:sldId id="260" r:id="rId11"/>
-    <p:sldId id="261" r:id="rId12"/>
-    <p:sldId id="262" r:id="rId13"/>
-    <p:sldId id="263" r:id="rId14"/>
-    <p:sldId id="264" r:id="rId15"/>
-    <p:sldId id="265" r:id="rId16"/>
+    <p:sldId id="256" r:id="rId2"/>
+    <p:sldId id="257" r:id="rId3"/>
+    <p:sldId id="258" r:id="rId4"/>
+    <p:sldId id="259" r:id="rId5"/>
+    <p:sldId id="260" r:id="rId6"/>
+    <p:sldId id="261" r:id="rId7"/>
+    <p:sldId id="262" r:id="rId8"/>
+    <p:sldId id="263" r:id="rId9"/>
+    <p:sldId id="264" r:id="rId10"/>
+    <p:sldId id="265" r:id="rId11"/>
   </p:sldIdLst>
-  <p:sldSz cx="12188952" cy="6858000" type="screen4x3"/>
+  <p:sldSz cx="12188825" cy="6858000"/>
   <p:notesSz cx="6858000" cy="9144000"/>
   <p:defaultTextStyle>
     <a:defPPr>
@@ -113,6 +113,22 @@
       </a:defRPr>
     </a:lvl9pPr>
   </p:defaultTextStyle>
+  <p:extLst>
+    <p:ext uri="{EFAFB233-063F-42B5-8137-9DF3F51BA10A}">
+      <p15:sldGuideLst xmlns:p15="http://schemas.microsoft.com/office/powerpoint/2012/main">
+        <p15:guide id="1" orient="horz" pos="2160">
+          <p15:clr>
+            <a:srgbClr val="A4A3A4"/>
+          </p15:clr>
+        </p15:guide>
+        <p15:guide id="2" pos="2880">
+          <p15:clr>
+            <a:srgbClr val="A4A3A4"/>
+          </p15:clr>
+        </p15:guide>
+      </p15:sldGuideLst>
+    </p:ext>
+  </p:extLst>
 </p:presentation>
 </file>
 
@@ -154,10 +170,9 @@
           <a:lstStyle/>
           <a:p>
             <a:r>
-              <a:rPr lang="en-US" smtClean="0"/>
+              <a:rPr lang="en-US"/>
               <a:t>Click to edit Master title style</a:t>
             </a:r>
-            <a:endParaRPr lang="en-US"/>
           </a:p>
         </p:txBody>
       </p:sp>
@@ -273,10 +288,9 @@
           </a:lstStyle>
           <a:p>
             <a:r>
-              <a:rPr lang="en-US" smtClean="0"/>
+              <a:rPr lang="en-US"/>
               <a:t>Click to edit Master subtitle style</a:t>
             </a:r>
-            <a:endParaRPr lang="en-US"/>
           </a:p>
         </p:txBody>
       </p:sp>
@@ -297,7 +311,7 @@
           <a:p>
             <a:fld id="{5BCAD085-E8A6-8845-BD4E-CB4CCA059FC4}" type="datetimeFigureOut">
               <a:rPr lang="en-US" smtClean="0"/>
-              <a:t>1/27/13</a:t>
+              <a:t>7/31/2026</a:t>
             </a:fld>
             <a:endParaRPr lang="en-US"/>
           </a:p>
@@ -391,10 +405,9 @@
           <a:lstStyle/>
           <a:p>
             <a:r>
-              <a:rPr lang="en-US" smtClean="0"/>
+              <a:rPr lang="en-US"/>
               <a:t>Click to edit Master title style</a:t>
             </a:r>
-            <a:endParaRPr lang="en-US"/>
           </a:p>
         </p:txBody>
       </p:sp>
@@ -415,38 +428,37 @@
           <a:p>
             <a:pPr lvl="0"/>
             <a:r>
-              <a:rPr lang="en-US" smtClean="0"/>
+              <a:rPr lang="en-US"/>
               <a:t>Click to edit Master text styles</a:t>
             </a:r>
           </a:p>
           <a:p>
             <a:pPr lvl="1"/>
             <a:r>
-              <a:rPr lang="en-US" smtClean="0"/>
+              <a:rPr lang="en-US"/>
               <a:t>Second level</a:t>
             </a:r>
           </a:p>
           <a:p>
             <a:pPr lvl="2"/>
             <a:r>
-              <a:rPr lang="en-US" smtClean="0"/>
+              <a:rPr lang="en-US"/>
               <a:t>Third level</a:t>
             </a:r>
           </a:p>
           <a:p>
             <a:pPr lvl="3"/>
             <a:r>
-              <a:rPr lang="en-US" smtClean="0"/>
+              <a:rPr lang="en-US"/>
               <a:t>Fourth level</a:t>
             </a:r>
           </a:p>
           <a:p>
             <a:pPr lvl="4"/>
             <a:r>
-              <a:rPr lang="en-US" smtClean="0"/>
+              <a:rPr lang="en-US"/>
               <a:t>Fifth level</a:t>
             </a:r>
-            <a:endParaRPr lang="en-US"/>
           </a:p>
         </p:txBody>
       </p:sp>
@@ -467,7 +479,7 @@
           <a:p>
             <a:fld id="{5BCAD085-E8A6-8845-BD4E-CB4CCA059FC4}" type="datetimeFigureOut">
               <a:rPr lang="en-US" smtClean="0"/>
-              <a:t>1/27/13</a:t>
+              <a:t>7/31/2026</a:t>
             </a:fld>
             <a:endParaRPr lang="en-US"/>
           </a:p>
@@ -566,10 +578,9 @@
           <a:lstStyle/>
           <a:p>
             <a:r>
-              <a:rPr lang="en-US" smtClean="0"/>
+              <a:rPr lang="en-US"/>
               <a:t>Click to edit Master title style</a:t>
             </a:r>
-            <a:endParaRPr lang="en-US"/>
           </a:p>
         </p:txBody>
       </p:sp>
@@ -595,38 +606,37 @@
           <a:p>
             <a:pPr lvl="0"/>
             <a:r>
-              <a:rPr lang="en-US" smtClean="0"/>
+              <a:rPr lang="en-US"/>
               <a:t>Click to edit Master text styles</a:t>
             </a:r>
           </a:p>
           <a:p>
             <a:pPr lvl="1"/>
             <a:r>
-              <a:rPr lang="en-US" smtClean="0"/>
+              <a:rPr lang="en-US"/>
               <a:t>Second level</a:t>
             </a:r>
           </a:p>
           <a:p>
             <a:pPr lvl="2"/>
             <a:r>
-              <a:rPr lang="en-US" smtClean="0"/>
+              <a:rPr lang="en-US"/>
               <a:t>Third level</a:t>
             </a:r>
           </a:p>
           <a:p>
             <a:pPr lvl="3"/>
             <a:r>
-              <a:rPr lang="en-US" smtClean="0"/>
+              <a:rPr lang="en-US"/>
               <a:t>Fourth level</a:t>
             </a:r>
           </a:p>
           <a:p>
             <a:pPr lvl="4"/>
             <a:r>
-              <a:rPr lang="en-US" smtClean="0"/>
+              <a:rPr lang="en-US"/>
               <a:t>Fifth level</a:t>
             </a:r>
-            <a:endParaRPr lang="en-US"/>
           </a:p>
         </p:txBody>
       </p:sp>
@@ -647,7 +657,7 @@
           <a:p>
             <a:fld id="{5BCAD085-E8A6-8845-BD4E-CB4CCA059FC4}" type="datetimeFigureOut">
               <a:rPr lang="en-US" smtClean="0"/>
-              <a:t>1/27/13</a:t>
+              <a:t>7/31/2026</a:t>
             </a:fld>
             <a:endParaRPr lang="en-US"/>
           </a:p>
@@ -741,10 +751,9 @@
           <a:lstStyle/>
           <a:p>
             <a:r>
-              <a:rPr lang="en-US" smtClean="0"/>
+              <a:rPr lang="en-US"/>
               <a:t>Click to edit Master title style</a:t>
             </a:r>
-            <a:endParaRPr lang="en-US"/>
           </a:p>
         </p:txBody>
       </p:sp>
@@ -765,38 +774,37 @@
           <a:p>
             <a:pPr lvl="0"/>
             <a:r>
-              <a:rPr lang="en-US" smtClean="0"/>
+              <a:rPr lang="en-US"/>
               <a:t>Click to edit Master text styles</a:t>
             </a:r>
           </a:p>
           <a:p>
             <a:pPr lvl="1"/>
             <a:r>
-              <a:rPr lang="en-US" smtClean="0"/>
+              <a:rPr lang="en-US"/>
               <a:t>Second level</a:t>
             </a:r>
           </a:p>
           <a:p>
             <a:pPr lvl="2"/>
             <a:r>
-              <a:rPr lang="en-US" smtClean="0"/>
+              <a:rPr lang="en-US"/>
               <a:t>Third level</a:t>
             </a:r>
           </a:p>
           <a:p>
             <a:pPr lvl="3"/>
             <a:r>
-              <a:rPr lang="en-US" smtClean="0"/>
+              <a:rPr lang="en-US"/>
               <a:t>Fourth level</a:t>
             </a:r>
           </a:p>
           <a:p>
             <a:pPr lvl="4"/>
             <a:r>
-              <a:rPr lang="en-US" smtClean="0"/>
+              <a:rPr lang="en-US"/>
               <a:t>Fifth level</a:t>
             </a:r>
-            <a:endParaRPr lang="en-US"/>
           </a:p>
         </p:txBody>
       </p:sp>
@@ -817,7 +825,7 @@
           <a:p>
             <a:fld id="{5BCAD085-E8A6-8845-BD4E-CB4CCA059FC4}" type="datetimeFigureOut">
               <a:rPr lang="en-US" smtClean="0"/>
-              <a:t>1/27/13</a:t>
+              <a:t>7/31/2026</a:t>
             </a:fld>
             <a:endParaRPr lang="en-US"/>
           </a:p>
@@ -920,10 +928,9 @@
           </a:lstStyle>
           <a:p>
             <a:r>
-              <a:rPr lang="en-US" smtClean="0"/>
+              <a:rPr lang="en-US"/>
               <a:t>Click to edit Master title style</a:t>
             </a:r>
-            <a:endParaRPr lang="en-US"/>
           </a:p>
         </p:txBody>
       </p:sp>
@@ -1040,7 +1047,7 @@
           <a:p>
             <a:pPr lvl="0"/>
             <a:r>
-              <a:rPr lang="en-US" smtClean="0"/>
+              <a:rPr lang="en-US"/>
               <a:t>Click to edit Master text styles</a:t>
             </a:r>
           </a:p>
@@ -1063,7 +1070,7 @@
           <a:p>
             <a:fld id="{5BCAD085-E8A6-8845-BD4E-CB4CCA059FC4}" type="datetimeFigureOut">
               <a:rPr lang="en-US" smtClean="0"/>
-              <a:t>1/27/13</a:t>
+              <a:t>7/31/2026</a:t>
             </a:fld>
             <a:endParaRPr lang="en-US"/>
           </a:p>
@@ -1157,10 +1164,9 @@
           <a:lstStyle/>
           <a:p>
             <a:r>
-              <a:rPr lang="en-US" smtClean="0"/>
+              <a:rPr lang="en-US"/>
               <a:t>Click to edit Master title style</a:t>
             </a:r>
-            <a:endParaRPr lang="en-US"/>
           </a:p>
         </p:txBody>
       </p:sp>
@@ -1214,38 +1220,37 @@
           <a:p>
             <a:pPr lvl="0"/>
             <a:r>
-              <a:rPr lang="en-US" smtClean="0"/>
+              <a:rPr lang="en-US"/>
               <a:t>Click to edit Master text styles</a:t>
             </a:r>
           </a:p>
           <a:p>
             <a:pPr lvl="1"/>
             <a:r>
-              <a:rPr lang="en-US" smtClean="0"/>
+              <a:rPr lang="en-US"/>
               <a:t>Second level</a:t>
             </a:r>
           </a:p>
           <a:p>
             <a:pPr lvl="2"/>
             <a:r>
-              <a:rPr lang="en-US" smtClean="0"/>
+              <a:rPr lang="en-US"/>
               <a:t>Third level</a:t>
             </a:r>
           </a:p>
           <a:p>
             <a:pPr lvl="3"/>
             <a:r>
-              <a:rPr lang="en-US" smtClean="0"/>
+              <a:rPr lang="en-US"/>
               <a:t>Fourth level</a:t>
             </a:r>
           </a:p>
           <a:p>
             <a:pPr lvl="4"/>
             <a:r>
-              <a:rPr lang="en-US" smtClean="0"/>
+              <a:rPr lang="en-US"/>
               <a:t>Fifth level</a:t>
             </a:r>
-            <a:endParaRPr lang="en-US"/>
           </a:p>
         </p:txBody>
       </p:sp>
@@ -1299,38 +1304,37 @@
           <a:p>
             <a:pPr lvl="0"/>
             <a:r>
-              <a:rPr lang="en-US" smtClean="0"/>
+              <a:rPr lang="en-US"/>
               <a:t>Click to edit Master text styles</a:t>
             </a:r>
           </a:p>
           <a:p>
             <a:pPr lvl="1"/>
             <a:r>
-              <a:rPr lang="en-US" smtClean="0"/>
+              <a:rPr lang="en-US"/>
               <a:t>Second level</a:t>
             </a:r>
           </a:p>
           <a:p>
             <a:pPr lvl="2"/>
             <a:r>
-              <a:rPr lang="en-US" smtClean="0"/>
+              <a:rPr lang="en-US"/>
               <a:t>Third level</a:t>
             </a:r>
           </a:p>
           <a:p>
             <a:pPr lvl="3"/>
             <a:r>
-              <a:rPr lang="en-US" smtClean="0"/>
+              <a:rPr lang="en-US"/>
               <a:t>Fourth level</a:t>
             </a:r>
           </a:p>
           <a:p>
             <a:pPr lvl="4"/>
             <a:r>
-              <a:rPr lang="en-US" smtClean="0"/>
+              <a:rPr lang="en-US"/>
               <a:t>Fifth level</a:t>
             </a:r>
-            <a:endParaRPr lang="en-US"/>
           </a:p>
         </p:txBody>
       </p:sp>
@@ -1351,7 +1355,7 @@
           <a:p>
             <a:fld id="{5BCAD085-E8A6-8845-BD4E-CB4CCA059FC4}" type="datetimeFigureOut">
               <a:rPr lang="en-US" smtClean="0"/>
-              <a:t>1/27/13</a:t>
+              <a:t>7/31/2026</a:t>
             </a:fld>
             <a:endParaRPr lang="en-US"/>
           </a:p>
@@ -1449,10 +1453,9 @@
           </a:lstStyle>
           <a:p>
             <a:r>
-              <a:rPr lang="en-US" smtClean="0"/>
+              <a:rPr lang="en-US"/>
               <a:t>Click to edit Master title style</a:t>
             </a:r>
-            <a:endParaRPr lang="en-US"/>
           </a:p>
         </p:txBody>
       </p:sp>
@@ -1515,7 +1518,7 @@
           <a:p>
             <a:pPr lvl="0"/>
             <a:r>
-              <a:rPr lang="en-US" smtClean="0"/>
+              <a:rPr lang="en-US"/>
               <a:t>Click to edit Master text styles</a:t>
             </a:r>
           </a:p>
@@ -1571,38 +1574,37 @@
           <a:p>
             <a:pPr lvl="0"/>
             <a:r>
-              <a:rPr lang="en-US" smtClean="0"/>
+              <a:rPr lang="en-US"/>
               <a:t>Click to edit Master text styles</a:t>
             </a:r>
           </a:p>
           <a:p>
             <a:pPr lvl="1"/>
             <a:r>
-              <a:rPr lang="en-US" smtClean="0"/>
+              <a:rPr lang="en-US"/>
               <a:t>Second level</a:t>
             </a:r>
           </a:p>
           <a:p>
             <a:pPr lvl="2"/>
             <a:r>
-              <a:rPr lang="en-US" smtClean="0"/>
+              <a:rPr lang="en-US"/>
               <a:t>Third level</a:t>
             </a:r>
           </a:p>
           <a:p>
             <a:pPr lvl="3"/>
             <a:r>
-              <a:rPr lang="en-US" smtClean="0"/>
+              <a:rPr lang="en-US"/>
               <a:t>Fourth level</a:t>
             </a:r>
           </a:p>
           <a:p>
             <a:pPr lvl="4"/>
             <a:r>
-              <a:rPr lang="en-US" smtClean="0"/>
+              <a:rPr lang="en-US"/>
               <a:t>Fifth level</a:t>
             </a:r>
-            <a:endParaRPr lang="en-US"/>
           </a:p>
         </p:txBody>
       </p:sp>
@@ -1665,7 +1667,7 @@
           <a:p>
             <a:pPr lvl="0"/>
             <a:r>
-              <a:rPr lang="en-US" smtClean="0"/>
+              <a:rPr lang="en-US"/>
               <a:t>Click to edit Master text styles</a:t>
             </a:r>
           </a:p>
@@ -1721,38 +1723,37 @@
           <a:p>
             <a:pPr lvl="0"/>
             <a:r>
-              <a:rPr lang="en-US" smtClean="0"/>
+              <a:rPr lang="en-US"/>
               <a:t>Click to edit Master text styles</a:t>
             </a:r>
           </a:p>
           <a:p>
             <a:pPr lvl="1"/>
             <a:r>
-              <a:rPr lang="en-US" smtClean="0"/>
+              <a:rPr lang="en-US"/>
               <a:t>Second level</a:t>
             </a:r>
           </a:p>
           <a:p>
             <a:pPr lvl="2"/>
             <a:r>
-              <a:rPr lang="en-US" smtClean="0"/>
+              <a:rPr lang="en-US"/>
               <a:t>Third level</a:t>
             </a:r>
           </a:p>
           <a:p>
             <a:pPr lvl="3"/>
             <a:r>
-              <a:rPr lang="en-US" smtClean="0"/>
+              <a:rPr lang="en-US"/>
               <a:t>Fourth level</a:t>
             </a:r>
           </a:p>
           <a:p>
             <a:pPr lvl="4"/>
             <a:r>
-              <a:rPr lang="en-US" smtClean="0"/>
+              <a:rPr lang="en-US"/>
               <a:t>Fifth level</a:t>
             </a:r>
-            <a:endParaRPr lang="en-US"/>
           </a:p>
         </p:txBody>
       </p:sp>
@@ -1773,7 +1774,7 @@
           <a:p>
             <a:fld id="{5BCAD085-E8A6-8845-BD4E-CB4CCA059FC4}" type="datetimeFigureOut">
               <a:rPr lang="en-US" smtClean="0"/>
-              <a:t>1/27/13</a:t>
+              <a:t>7/31/2026</a:t>
             </a:fld>
             <a:endParaRPr lang="en-US"/>
           </a:p>
@@ -1867,10 +1868,9 @@
           <a:lstStyle/>
           <a:p>
             <a:r>
-              <a:rPr lang="en-US" smtClean="0"/>
+              <a:rPr lang="en-US"/>
               <a:t>Click to edit Master title style</a:t>
             </a:r>
-            <a:endParaRPr lang="en-US"/>
           </a:p>
         </p:txBody>
       </p:sp>
@@ -1891,7 +1891,7 @@
           <a:p>
             <a:fld id="{5BCAD085-E8A6-8845-BD4E-CB4CCA059FC4}" type="datetimeFigureOut">
               <a:rPr lang="en-US" smtClean="0"/>
-              <a:t>1/27/13</a:t>
+              <a:t>7/31/2026</a:t>
             </a:fld>
             <a:endParaRPr lang="en-US"/>
           </a:p>
@@ -1986,7 +1986,7 @@
           <a:p>
             <a:fld id="{5BCAD085-E8A6-8845-BD4E-CB4CCA059FC4}" type="datetimeFigureOut">
               <a:rPr lang="en-US" smtClean="0"/>
-              <a:t>1/27/13</a:t>
+              <a:t>7/31/2026</a:t>
             </a:fld>
             <a:endParaRPr lang="en-US"/>
           </a:p>
@@ -2089,10 +2089,9 @@
           </a:lstStyle>
           <a:p>
             <a:r>
-              <a:rPr lang="en-US" smtClean="0"/>
+              <a:rPr lang="en-US"/>
               <a:t>Click to edit Master title style</a:t>
             </a:r>
-            <a:endParaRPr lang="en-US"/>
           </a:p>
         </p:txBody>
       </p:sp>
@@ -2146,38 +2145,37 @@
           <a:p>
             <a:pPr lvl="0"/>
             <a:r>
-              <a:rPr lang="en-US" smtClean="0"/>
+              <a:rPr lang="en-US"/>
               <a:t>Click to edit Master text styles</a:t>
             </a:r>
           </a:p>
           <a:p>
             <a:pPr lvl="1"/>
             <a:r>
-              <a:rPr lang="en-US" smtClean="0"/>
+              <a:rPr lang="en-US"/>
               <a:t>Second level</a:t>
             </a:r>
           </a:p>
           <a:p>
             <a:pPr lvl="2"/>
             <a:r>
-              <a:rPr lang="en-US" smtClean="0"/>
+              <a:rPr lang="en-US"/>
               <a:t>Third level</a:t>
             </a:r>
           </a:p>
           <a:p>
             <a:pPr lvl="3"/>
             <a:r>
-              <a:rPr lang="en-US" smtClean="0"/>
+              <a:rPr lang="en-US"/>
               <a:t>Fourth level</a:t>
             </a:r>
           </a:p>
           <a:p>
             <a:pPr lvl="4"/>
             <a:r>
-              <a:rPr lang="en-US" smtClean="0"/>
+              <a:rPr lang="en-US"/>
               <a:t>Fifth level</a:t>
             </a:r>
-            <a:endParaRPr lang="en-US"/>
           </a:p>
         </p:txBody>
       </p:sp>
@@ -2240,7 +2238,7 @@
           <a:p>
             <a:pPr lvl="0"/>
             <a:r>
-              <a:rPr lang="en-US" smtClean="0"/>
+              <a:rPr lang="en-US"/>
               <a:t>Click to edit Master text styles</a:t>
             </a:r>
           </a:p>
@@ -2263,7 +2261,7 @@
           <a:p>
             <a:fld id="{5BCAD085-E8A6-8845-BD4E-CB4CCA059FC4}" type="datetimeFigureOut">
               <a:rPr lang="en-US" smtClean="0"/>
-              <a:t>1/27/13</a:t>
+              <a:t>7/31/2026</a:t>
             </a:fld>
             <a:endParaRPr lang="en-US"/>
           </a:p>
@@ -2366,10 +2364,9 @@
           </a:lstStyle>
           <a:p>
             <a:r>
-              <a:rPr lang="en-US" smtClean="0"/>
+              <a:rPr lang="en-US"/>
               <a:t>Click to edit Master title style</a:t>
             </a:r>
-            <a:endParaRPr lang="en-US"/>
           </a:p>
         </p:txBody>
       </p:sp>
@@ -2493,7 +2490,7 @@
           <a:p>
             <a:pPr lvl="0"/>
             <a:r>
-              <a:rPr lang="en-US" smtClean="0"/>
+              <a:rPr lang="en-US"/>
               <a:t>Click to edit Master text styles</a:t>
             </a:r>
           </a:p>
@@ -2516,7 +2513,7 @@
           <a:p>
             <a:fld id="{5BCAD085-E8A6-8845-BD4E-CB4CCA059FC4}" type="datetimeFigureOut">
               <a:rPr lang="en-US" smtClean="0"/>
-              <a:t>1/27/13</a:t>
+              <a:t>7/31/2026</a:t>
             </a:fld>
             <a:endParaRPr lang="en-US"/>
           </a:p>
@@ -2625,10 +2622,9 @@
           <a:lstStyle/>
           <a:p>
             <a:r>
-              <a:rPr lang="en-US" smtClean="0"/>
+              <a:rPr lang="en-US"/>
               <a:t>Click to edit Master title style</a:t>
             </a:r>
-            <a:endParaRPr lang="en-US"/>
           </a:p>
         </p:txBody>
       </p:sp>
@@ -2659,38 +2655,37 @@
           <a:p>
             <a:pPr lvl="0"/>
             <a:r>
-              <a:rPr lang="en-US" smtClean="0"/>
+              <a:rPr lang="en-US"/>
               <a:t>Click to edit Master text styles</a:t>
             </a:r>
           </a:p>
           <a:p>
             <a:pPr lvl="1"/>
             <a:r>
-              <a:rPr lang="en-US" smtClean="0"/>
+              <a:rPr lang="en-US"/>
               <a:t>Second level</a:t>
             </a:r>
           </a:p>
           <a:p>
             <a:pPr lvl="2"/>
             <a:r>
-              <a:rPr lang="en-US" smtClean="0"/>
+              <a:rPr lang="en-US"/>
               <a:t>Third level</a:t>
             </a:r>
           </a:p>
           <a:p>
             <a:pPr lvl="3"/>
             <a:r>
-              <a:rPr lang="en-US" smtClean="0"/>
+              <a:rPr lang="en-US"/>
               <a:t>Fourth level</a:t>
             </a:r>
           </a:p>
           <a:p>
             <a:pPr lvl="4"/>
             <a:r>
-              <a:rPr lang="en-US" smtClean="0"/>
+              <a:rPr lang="en-US"/>
               <a:t>Fifth level</a:t>
             </a:r>
-            <a:endParaRPr lang="en-US"/>
           </a:p>
         </p:txBody>
       </p:sp>
@@ -2729,7 +2724,7 @@
           <a:p>
             <a:fld id="{5BCAD085-E8A6-8845-BD4E-CB4CCA059FC4}" type="datetimeFigureOut">
               <a:rPr lang="en-US" smtClean="0"/>
-              <a:t>1/27/13</a:t>
+              <a:t>7/31/2026</a:t>
             </a:fld>
             <a:endParaRPr lang="en-US"/>
           </a:p>
@@ -3088,7 +3083,7 @@
 </file>
 
 <file path=ppt/slides/slide1.xml><?xml version="1.0" encoding="utf-8"?>
-<p:sld xmlns:a="http://schemas.openxmlformats.org/drawingml/2006/main" xmlns:p="http://schemas.openxmlformats.org/presentationml/2006/main" xmlns:r="http://schemas.openxmlformats.org/officeDocument/2006/relationships">
+<p:sld xmlns:a="http://schemas.openxmlformats.org/drawingml/2006/main" xmlns:r="http://schemas.openxmlformats.org/officeDocument/2006/relationships" xmlns:p="http://schemas.openxmlformats.org/presentationml/2006/main">
   <p:cSld>
     <p:bg>
       <p:bgPr>
@@ -3104,7 +3099,14 @@
         <p:cNvGrpSpPr/>
         <p:nvPr/>
       </p:nvGrpSpPr>
-      <p:grpSpPr/>
+      <p:grpSpPr>
+        <a:xfrm>
+          <a:off x="0" y="0"/>
+          <a:ext cx="0" cy="0"/>
+          <a:chOff x="0" y="0"/>
+          <a:chExt cx="0" cy="0"/>
+        </a:xfrm>
+      </p:grpSpPr>
       <p:sp>
         <p:nvSpPr>
           <p:cNvPr id="2" name="Rectangle 1"/>
@@ -3145,6 +3147,7 @@
           <a:lstStyle/>
           <a:p>
             <a:pPr algn="ctr"/>
+            <a:endParaRPr/>
           </a:p>
         </p:txBody>
       </p:sp>
@@ -3290,6 +3293,7 @@
           <a:lstStyle/>
           <a:p>
             <a:pPr algn="ctr"/>
+            <a:endParaRPr/>
           </a:p>
         </p:txBody>
       </p:sp>
@@ -3370,6 +3374,7 @@
           <a:lstStyle/>
           <a:p>
             <a:pPr algn="ctr"/>
+            <a:endParaRPr/>
           </a:p>
         </p:txBody>
       </p:sp>
@@ -3483,6 +3488,7 @@
           <a:lstStyle/>
           <a:p>
             <a:pPr algn="ctr"/>
+            <a:endParaRPr/>
           </a:p>
         </p:txBody>
       </p:sp>
@@ -3596,6 +3602,7 @@
           <a:lstStyle/>
           <a:p>
             <a:pPr algn="ctr"/>
+            <a:endParaRPr/>
           </a:p>
         </p:txBody>
       </p:sp>
@@ -3709,6 +3716,7 @@
           <a:lstStyle/>
           <a:p>
             <a:pPr algn="ctr"/>
+            <a:endParaRPr/>
           </a:p>
         </p:txBody>
       </p:sp>
@@ -3820,6 +3828,7 @@
           <a:lstStyle/>
           <a:p>
             <a:pPr algn="ctr"/>
+            <a:endParaRPr/>
           </a:p>
         </p:txBody>
       </p:sp>
@@ -3866,7 +3875,7 @@
 </file>
 
 <file path=ppt/slides/slide10.xml><?xml version="1.0" encoding="utf-8"?>
-<p:sld xmlns:a="http://schemas.openxmlformats.org/drawingml/2006/main" xmlns:p="http://schemas.openxmlformats.org/presentationml/2006/main" xmlns:r="http://schemas.openxmlformats.org/officeDocument/2006/relationships">
+<p:sld xmlns:a="http://schemas.openxmlformats.org/drawingml/2006/main" xmlns:r="http://schemas.openxmlformats.org/officeDocument/2006/relationships" xmlns:p="http://schemas.openxmlformats.org/presentationml/2006/main">
   <p:cSld>
     <p:bg>
       <p:bgPr>
@@ -3882,7 +3891,14 @@
         <p:cNvGrpSpPr/>
         <p:nvPr/>
       </p:nvGrpSpPr>
-      <p:grpSpPr/>
+      <p:grpSpPr>
+        <a:xfrm>
+          <a:off x="0" y="0"/>
+          <a:ext cx="0" cy="0"/>
+          <a:chOff x="0" y="0"/>
+          <a:chExt cx="0" cy="0"/>
+        </a:xfrm>
+      </p:grpSpPr>
       <p:sp>
         <p:nvSpPr>
           <p:cNvPr id="2" name="Rectangle 1"/>
@@ -3923,6 +3939,7 @@
           <a:lstStyle/>
           <a:p>
             <a:pPr algn="ctr"/>
+            <a:endParaRPr/>
           </a:p>
         </p:txBody>
       </p:sp>
@@ -4000,6 +4017,7 @@
           <a:lstStyle/>
           <a:p>
             <a:pPr algn="ctr"/>
+            <a:endParaRPr/>
           </a:p>
         </p:txBody>
       </p:sp>
@@ -4045,6 +4063,7 @@
           <a:lstStyle/>
           <a:p>
             <a:pPr algn="ctr"/>
+            <a:endParaRPr/>
           </a:p>
         </p:txBody>
       </p:sp>
@@ -4072,7 +4091,7 @@
           <a:p>
             <a:pPr algn="l"/>
             <a:r>
-              <a:rPr sz="1600" b="1">
+              <a:rPr sz="1600" b="1" dirty="0">
                 <a:solidFill>
                   <a:srgbClr val="10B981"/>
                 </a:solidFill>
@@ -4396,6 +4415,7 @@
           <a:lstStyle/>
           <a:p>
             <a:pPr algn="ctr"/>
+            <a:endParaRPr/>
           </a:p>
         </p:txBody>
       </p:sp>
@@ -4408,27 +4428,27 @@
         <p:spPr>
           <a:xfrm>
             <a:off x="6309360" y="1325880"/>
-            <a:ext cx="5029200" cy="411480"/>
-          </a:xfrm>
-          <a:prstGeom prst="rect">
-            <a:avLst/>
-          </a:prstGeom>
-          <a:noFill/>
-        </p:spPr>
-        <p:txBody>
-          <a:bodyPr wrap="square">
-            <a:spAutoFit/>
-          </a:bodyPr>
-          <a:lstStyle/>
-          <a:p>
-            <a:pPr algn="l"/>
-            <a:r>
-              <a:rPr sz="1600" b="1">
+            <a:ext cx="5029200" cy="338554"/>
+          </a:xfrm>
+          <a:prstGeom prst="rect">
+            <a:avLst/>
+          </a:prstGeom>
+          <a:noFill/>
+        </p:spPr>
+        <p:txBody>
+          <a:bodyPr wrap="square">
+            <a:spAutoFit/>
+          </a:bodyPr>
+          <a:lstStyle/>
+          <a:p>
+            <a:pPr algn="l"/>
+            <a:r>
+              <a:rPr sz="1600" b="1" dirty="0">
                 <a:solidFill>
                   <a:srgbClr val="3B82F6"/>
                 </a:solidFill>
               </a:rPr>
-              <a:t>🚀  Next Steps</a:t>
+              <a:t>Next Steps</a:t>
             </a:r>
           </a:p>
         </p:txBody>
@@ -4457,7 +4477,7 @@
           <a:p>
             <a:pPr algn="l"/>
             <a:r>
-              <a:rPr sz="1000" b="0">
+              <a:rPr sz="1000" b="0" dirty="0">
                 <a:solidFill>
                   <a:srgbClr val="94A3B8"/>
                 </a:solidFill>
@@ -4648,6 +4668,7 @@
           <a:lstStyle/>
           <a:p>
             <a:pPr algn="ctr"/>
+            <a:endParaRPr/>
           </a:p>
         </p:txBody>
       </p:sp>
@@ -4694,7 +4715,7 @@
 </file>
 
 <file path=ppt/slides/slide2.xml><?xml version="1.0" encoding="utf-8"?>
-<p:sld xmlns:a="http://schemas.openxmlformats.org/drawingml/2006/main" xmlns:p="http://schemas.openxmlformats.org/presentationml/2006/main" xmlns:r="http://schemas.openxmlformats.org/officeDocument/2006/relationships">
+<p:sld xmlns:a="http://schemas.openxmlformats.org/drawingml/2006/main" xmlns:r="http://schemas.openxmlformats.org/officeDocument/2006/relationships" xmlns:p="http://schemas.openxmlformats.org/presentationml/2006/main">
   <p:cSld>
     <p:bg>
       <p:bgPr>
@@ -4710,7 +4731,14 @@
         <p:cNvGrpSpPr/>
         <p:nvPr/>
       </p:nvGrpSpPr>
-      <p:grpSpPr/>
+      <p:grpSpPr>
+        <a:xfrm>
+          <a:off x="0" y="0"/>
+          <a:ext cx="0" cy="0"/>
+          <a:chOff x="0" y="0"/>
+          <a:chExt cx="0" cy="0"/>
+        </a:xfrm>
+      </p:grpSpPr>
       <p:sp>
         <p:nvSpPr>
           <p:cNvPr id="2" name="Rectangle 1"/>
@@ -4751,6 +4779,7 @@
           <a:lstStyle/>
           <a:p>
             <a:pPr algn="ctr"/>
+            <a:endParaRPr/>
           </a:p>
         </p:txBody>
       </p:sp>
@@ -4828,6 +4857,7 @@
           <a:lstStyle/>
           <a:p>
             <a:pPr algn="ctr"/>
+            <a:endParaRPr/>
           </a:p>
         </p:txBody>
       </p:sp>
@@ -4907,6 +4937,7 @@
           <a:lstStyle/>
           <a:p>
             <a:pPr algn="ctr"/>
+            <a:endParaRPr/>
           </a:p>
         </p:txBody>
       </p:sp>
@@ -4919,27 +4950,27 @@
         <p:spPr>
           <a:xfrm>
             <a:off x="548640" y="1856231"/>
-            <a:ext cx="4572000" cy="365760"/>
-          </a:xfrm>
-          <a:prstGeom prst="rect">
-            <a:avLst/>
-          </a:prstGeom>
-          <a:noFill/>
-        </p:spPr>
-        <p:txBody>
-          <a:bodyPr wrap="square">
-            <a:spAutoFit/>
-          </a:bodyPr>
-          <a:lstStyle/>
-          <a:p>
-            <a:pPr algn="l"/>
-            <a:r>
-              <a:rPr sz="1400" b="1">
+            <a:ext cx="4572000" cy="307777"/>
+          </a:xfrm>
+          <a:prstGeom prst="rect">
+            <a:avLst/>
+          </a:prstGeom>
+          <a:noFill/>
+        </p:spPr>
+        <p:txBody>
+          <a:bodyPr wrap="square">
+            <a:spAutoFit/>
+          </a:bodyPr>
+          <a:lstStyle/>
+          <a:p>
+            <a:pPr algn="l"/>
+            <a:r>
+              <a:rPr sz="1400" b="1" dirty="0">
                 <a:solidFill>
                   <a:srgbClr val="EF4444"/>
                 </a:solidFill>
               </a:rPr>
-              <a:t>⚡ 280W wasted per request</a:t>
+              <a:t>280W wasted per request</a:t>
             </a:r>
           </a:p>
         </p:txBody>
@@ -5020,6 +5051,7 @@
           <a:lstStyle/>
           <a:p>
             <a:pPr algn="ctr"/>
+            <a:endParaRPr/>
           </a:p>
         </p:txBody>
       </p:sp>
@@ -5032,27 +5064,27 @@
         <p:spPr>
           <a:xfrm>
             <a:off x="548640" y="2907791"/>
-            <a:ext cx="4572000" cy="365760"/>
-          </a:xfrm>
-          <a:prstGeom prst="rect">
-            <a:avLst/>
-          </a:prstGeom>
-          <a:noFill/>
-        </p:spPr>
-        <p:txBody>
-          <a:bodyPr wrap="square">
-            <a:spAutoFit/>
-          </a:bodyPr>
-          <a:lstStyle/>
-          <a:p>
-            <a:pPr algn="l"/>
-            <a:r>
-              <a:rPr sz="1400" b="1">
+            <a:ext cx="4572000" cy="307777"/>
+          </a:xfrm>
+          <a:prstGeom prst="rect">
+            <a:avLst/>
+          </a:prstGeom>
+          <a:noFill/>
+        </p:spPr>
+        <p:txBody>
+          <a:bodyPr wrap="square">
+            <a:spAutoFit/>
+          </a:bodyPr>
+          <a:lstStyle/>
+          <a:p>
+            <a:pPr algn="l"/>
+            <a:r>
+              <a:rPr sz="1400" b="1" dirty="0">
                 <a:solidFill>
                   <a:srgbClr val="EF4444"/>
                 </a:solidFill>
               </a:rPr>
-              <a:t>⏱  4,800ms added latency</a:t>
+              <a:t>4,800ms added latency</a:t>
             </a:r>
           </a:p>
         </p:txBody>
@@ -5133,6 +5165,7 @@
           <a:lstStyle/>
           <a:p>
             <a:pPr algn="ctr"/>
+            <a:endParaRPr/>
           </a:p>
         </p:txBody>
       </p:sp>
@@ -5145,27 +5178,27 @@
         <p:spPr>
           <a:xfrm>
             <a:off x="548640" y="3959352"/>
-            <a:ext cx="4572000" cy="365760"/>
-          </a:xfrm>
-          <a:prstGeom prst="rect">
-            <a:avLst/>
-          </a:prstGeom>
-          <a:noFill/>
-        </p:spPr>
-        <p:txBody>
-          <a:bodyPr wrap="square">
-            <a:spAutoFit/>
-          </a:bodyPr>
-          <a:lstStyle/>
-          <a:p>
-            <a:pPr algn="l"/>
-            <a:r>
-              <a:rPr sz="1400" b="1">
+            <a:ext cx="4572000" cy="307777"/>
+          </a:xfrm>
+          <a:prstGeom prst="rect">
+            <a:avLst/>
+          </a:prstGeom>
+          <a:noFill/>
+        </p:spPr>
+        <p:txBody>
+          <a:bodyPr wrap="square">
+            <a:spAutoFit/>
+          </a:bodyPr>
+          <a:lstStyle/>
+          <a:p>
+            <a:pPr algn="l"/>
+            <a:r>
+              <a:rPr sz="1400" b="1" dirty="0">
                 <a:solidFill>
                   <a:srgbClr val="EF4444"/>
                 </a:solidFill>
               </a:rPr>
-              <a:t>🧠 VRAM saturated at 100%</a:t>
+              <a:t>VRAM saturated at 100%</a:t>
             </a:r>
           </a:p>
         </p:txBody>
@@ -5246,6 +5279,7 @@
           <a:lstStyle/>
           <a:p>
             <a:pPr algn="ctr"/>
+            <a:endParaRPr/>
           </a:p>
         </p:txBody>
       </p:sp>
@@ -5258,27 +5292,27 @@
         <p:spPr>
           <a:xfrm>
             <a:off x="548640" y="5010912"/>
-            <a:ext cx="4572000" cy="365760"/>
-          </a:xfrm>
-          <a:prstGeom prst="rect">
-            <a:avLst/>
-          </a:prstGeom>
-          <a:noFill/>
-        </p:spPr>
-        <p:txBody>
-          <a:bodyPr wrap="square">
-            <a:spAutoFit/>
-          </a:bodyPr>
-          <a:lstStyle/>
-          <a:p>
-            <a:pPr algn="l"/>
-            <a:r>
-              <a:rPr sz="1400" b="1">
+            <a:ext cx="4572000" cy="307777"/>
+          </a:xfrm>
+          <a:prstGeom prst="rect">
+            <a:avLst/>
+          </a:prstGeom>
+          <a:noFill/>
+        </p:spPr>
+        <p:txBody>
+          <a:bodyPr wrap="square">
+            <a:spAutoFit/>
+          </a:bodyPr>
+          <a:lstStyle/>
+          <a:p>
+            <a:pPr algn="l"/>
+            <a:r>
+              <a:rPr sz="1400" b="1" dirty="0">
                 <a:solidFill>
                   <a:srgbClr val="EF4444"/>
                 </a:solidFill>
               </a:rPr>
-              <a:t>💸 Over-provisioned hardware</a:t>
+              <a:t>Over-provisioned hardware</a:t>
             </a:r>
           </a:p>
         </p:txBody>
@@ -5360,7 +5394,7 @@
 </file>
 
 <file path=ppt/slides/slide3.xml><?xml version="1.0" encoding="utf-8"?>
-<p:sld xmlns:a="http://schemas.openxmlformats.org/drawingml/2006/main" xmlns:p="http://schemas.openxmlformats.org/presentationml/2006/main" xmlns:r="http://schemas.openxmlformats.org/officeDocument/2006/relationships">
+<p:sld xmlns:a="http://schemas.openxmlformats.org/drawingml/2006/main" xmlns:r="http://schemas.openxmlformats.org/officeDocument/2006/relationships" xmlns:p="http://schemas.openxmlformats.org/presentationml/2006/main">
   <p:cSld>
     <p:bg>
       <p:bgPr>
@@ -5376,7 +5410,14 @@
         <p:cNvGrpSpPr/>
         <p:nvPr/>
       </p:nvGrpSpPr>
-      <p:grpSpPr/>
+      <p:grpSpPr>
+        <a:xfrm>
+          <a:off x="0" y="0"/>
+          <a:ext cx="0" cy="0"/>
+          <a:chOff x="0" y="0"/>
+          <a:chExt cx="0" cy="0"/>
+        </a:xfrm>
+      </p:grpSpPr>
       <p:sp>
         <p:nvSpPr>
           <p:cNvPr id="2" name="Rectangle 1"/>
@@ -5417,6 +5458,7 @@
           <a:lstStyle/>
           <a:p>
             <a:pPr algn="ctr"/>
+            <a:endParaRPr/>
           </a:p>
         </p:txBody>
       </p:sp>
@@ -5494,6 +5536,7 @@
           <a:lstStyle/>
           <a:p>
             <a:pPr algn="ctr"/>
+            <a:endParaRPr/>
           </a:p>
         </p:txBody>
       </p:sp>
@@ -5607,6 +5650,7 @@
           <a:lstStyle/>
           <a:p>
             <a:pPr algn="ctr"/>
+            <a:endParaRPr/>
           </a:p>
         </p:txBody>
       </p:sp>
@@ -5856,6 +5900,7 @@
           <a:lstStyle/>
           <a:p>
             <a:pPr algn="ctr"/>
+            <a:endParaRPr/>
           </a:p>
         </p:txBody>
       </p:sp>
@@ -6105,6 +6150,7 @@
           <a:lstStyle/>
           <a:p>
             <a:pPr algn="ctr"/>
+            <a:endParaRPr/>
           </a:p>
         </p:txBody>
       </p:sp>
@@ -6321,7 +6367,7 @@
         <p:spPr>
           <a:xfrm>
             <a:off x="457200" y="4663440"/>
-            <a:ext cx="11247120" cy="685800"/>
+            <a:ext cx="11247120" cy="777240"/>
           </a:xfrm>
           <a:prstGeom prst="rect">
             <a:avLst/>
@@ -6354,6 +6400,7 @@
           <a:lstStyle/>
           <a:p>
             <a:pPr algn="ctr"/>
+            <a:endParaRPr/>
           </a:p>
         </p:txBody>
       </p:sp>
@@ -6400,28 +6447,57 @@
         <p:spPr>
           <a:xfrm>
             <a:off x="1097280" y="4709159"/>
-            <a:ext cx="3657600" cy="320040"/>
-          </a:xfrm>
-          <a:prstGeom prst="rect">
-            <a:avLst/>
-          </a:prstGeom>
-          <a:noFill/>
-        </p:spPr>
-        <p:txBody>
-          <a:bodyPr wrap="square">
-            <a:spAutoFit/>
-          </a:bodyPr>
-          <a:lstStyle/>
-          <a:p>
-            <a:pPr algn="l"/>
-            <a:r>
-              <a:rPr sz="1300" b="1">
+            <a:ext cx="3657600" cy="692497"/>
+          </a:xfrm>
+          <a:prstGeom prst="rect">
+            <a:avLst/>
+          </a:prstGeom>
+          <a:noFill/>
+        </p:spPr>
+        <p:txBody>
+          <a:bodyPr wrap="square">
+            <a:spAutoFit/>
+          </a:bodyPr>
+          <a:lstStyle/>
+          <a:p>
+            <a:pPr algn="l"/>
+            <a:r>
+              <a:rPr sz="1300" b="1" dirty="0">
                 <a:solidFill>
                   <a:srgbClr val="FFFFFF"/>
                 </a:solidFill>
               </a:rPr>
-              <a:t>Tier 3: AMD ROCm LLM (Qwen2.5-Coder-7B on W7900)</a:t>
-            </a:r>
+              <a:t>Tier 3: AMD </a:t>
+            </a:r>
+            <a:r>
+              <a:rPr sz="1300" b="1" dirty="0" err="1">
+                <a:solidFill>
+                  <a:srgbClr val="FFFFFF"/>
+                </a:solidFill>
+              </a:rPr>
+              <a:t>ROCm</a:t>
+            </a:r>
+            <a:r>
+              <a:rPr sz="1300" b="1" dirty="0">
+                <a:solidFill>
+                  <a:srgbClr val="FFFFFF"/>
+                </a:solidFill>
+              </a:rPr>
+              <a:t> LLM (Qwen2.5-Coder-7B on W7900)</a:t>
+            </a:r>
+            <a:endParaRPr lang="en-US" sz="1300" b="1" dirty="0">
+              <a:solidFill>
+                <a:srgbClr val="FFFFFF"/>
+              </a:solidFill>
+            </a:endParaRPr>
+          </a:p>
+          <a:p>
+            <a:pPr algn="l"/>
+            <a:endParaRPr sz="1300" b="1" dirty="0">
+              <a:solidFill>
+                <a:srgbClr val="FFFFFF"/>
+              </a:solidFill>
+            </a:endParaRPr>
           </a:p>
         </p:txBody>
       </p:sp>
@@ -6433,7 +6509,7 @@
         </p:nvSpPr>
         <p:spPr>
           <a:xfrm>
-            <a:off x="1097280" y="5029200"/>
+            <a:off x="1097280" y="5152768"/>
             <a:ext cx="5029200" cy="274320"/>
           </a:xfrm>
           <a:prstGeom prst="rect">
@@ -6449,7 +6525,7 @@
           <a:p>
             <a:pPr algn="l"/>
             <a:r>
-              <a:rPr sz="1000" b="0">
+              <a:rPr sz="1000" b="0" dirty="0">
                 <a:solidFill>
                   <a:srgbClr val="94A3B8"/>
                 </a:solidFill>
@@ -6501,7 +6577,7 @@
         </p:nvSpPr>
         <p:spPr>
           <a:xfrm>
-            <a:off x="8686800" y="5029200"/>
+            <a:off x="8686800" y="5152768"/>
             <a:ext cx="1463040" cy="274320"/>
           </a:xfrm>
           <a:prstGeom prst="rect">
@@ -6517,7 +6593,7 @@
           <a:p>
             <a:pPr algn="r"/>
             <a:r>
-              <a:rPr sz="1000" b="0">
+              <a:rPr sz="1000" b="0" dirty="0">
                 <a:solidFill>
                   <a:srgbClr val="94A3B8"/>
                 </a:solidFill>
@@ -6569,7 +6645,7 @@
         </p:nvSpPr>
         <p:spPr>
           <a:xfrm>
-            <a:off x="365760" y="5532120"/>
+            <a:off x="365760" y="5600080"/>
             <a:ext cx="11430000" cy="365760"/>
           </a:xfrm>
           <a:prstGeom prst="rect">
@@ -6585,7 +6661,7 @@
           <a:p>
             <a:pPr algn="ctr"/>
             <a:r>
-              <a:rPr sz="1200" b="1">
+              <a:rPr sz="1200" b="1" dirty="0">
                 <a:solidFill>
                   <a:srgbClr val="10B981"/>
                 </a:solidFill>
@@ -6604,7 +6680,7 @@
 </file>
 
 <file path=ppt/slides/slide4.xml><?xml version="1.0" encoding="utf-8"?>
-<p:sld xmlns:a="http://schemas.openxmlformats.org/drawingml/2006/main" xmlns:p="http://schemas.openxmlformats.org/presentationml/2006/main" xmlns:r="http://schemas.openxmlformats.org/officeDocument/2006/relationships">
+<p:sld xmlns:a="http://schemas.openxmlformats.org/drawingml/2006/main" xmlns:r="http://schemas.openxmlformats.org/officeDocument/2006/relationships" xmlns:p="http://schemas.openxmlformats.org/presentationml/2006/main">
   <p:cSld>
     <p:bg>
       <p:bgPr>
@@ -6620,7 +6696,14 @@
         <p:cNvGrpSpPr/>
         <p:nvPr/>
       </p:nvGrpSpPr>
-      <p:grpSpPr/>
+      <p:grpSpPr>
+        <a:xfrm>
+          <a:off x="0" y="0"/>
+          <a:ext cx="0" cy="0"/>
+          <a:chOff x="0" y="0"/>
+          <a:chExt cx="0" cy="0"/>
+        </a:xfrm>
+      </p:grpSpPr>
       <p:sp>
         <p:nvSpPr>
           <p:cNvPr id="2" name="Rectangle 1"/>
@@ -6661,6 +6744,7 @@
           <a:lstStyle/>
           <a:p>
             <a:pPr algn="ctr"/>
+            <a:endParaRPr/>
           </a:p>
         </p:txBody>
       </p:sp>
@@ -6738,6 +6822,7 @@
           <a:lstStyle/>
           <a:p>
             <a:pPr algn="ctr"/>
+            <a:endParaRPr/>
           </a:p>
         </p:txBody>
       </p:sp>
@@ -6817,6 +6902,7 @@
           <a:lstStyle/>
           <a:p>
             <a:pPr algn="ctr"/>
+            <a:endParaRPr/>
           </a:p>
         </p:txBody>
       </p:sp>
@@ -6931,6 +7017,7 @@
           <a:lstStyle/>
           <a:p>
             <a:pPr algn="ctr"/>
+            <a:endParaRPr/>
           </a:p>
         </p:txBody>
       </p:sp>
@@ -7045,6 +7132,7 @@
           <a:lstStyle/>
           <a:p>
             <a:pPr algn="ctr"/>
+            <a:endParaRPr/>
           </a:p>
         </p:txBody>
       </p:sp>
@@ -7159,6 +7247,7 @@
           <a:lstStyle/>
           <a:p>
             <a:pPr algn="ctr"/>
+            <a:endParaRPr/>
           </a:p>
         </p:txBody>
       </p:sp>
@@ -7305,6 +7394,7 @@
           <a:lstStyle/>
           <a:p>
             <a:pPr algn="ctr"/>
+            <a:endParaRPr/>
           </a:p>
         </p:txBody>
       </p:sp>
@@ -7450,6 +7540,7 @@
           <a:lstStyle/>
           <a:p>
             <a:pPr algn="ctr"/>
+            <a:endParaRPr/>
           </a:p>
         </p:txBody>
       </p:sp>
@@ -7595,6 +7686,7 @@
           <a:lstStyle/>
           <a:p>
             <a:pPr algn="ctr"/>
+            <a:endParaRPr/>
           </a:p>
         </p:txBody>
       </p:sp>
@@ -7740,6 +7832,7 @@
           <a:lstStyle/>
           <a:p>
             <a:pPr algn="ctr"/>
+            <a:endParaRPr/>
           </a:p>
         </p:txBody>
       </p:sp>
@@ -7885,6 +7978,7 @@
           <a:lstStyle/>
           <a:p>
             <a:pPr algn="ctr"/>
+            <a:endParaRPr/>
           </a:p>
         </p:txBody>
       </p:sp>
@@ -8030,6 +8124,7 @@
           <a:lstStyle/>
           <a:p>
             <a:pPr algn="ctr"/>
+            <a:endParaRPr/>
           </a:p>
         </p:txBody>
       </p:sp>
@@ -8175,6 +8270,7 @@
           <a:lstStyle/>
           <a:p>
             <a:pPr algn="ctr"/>
+            <a:endParaRPr/>
           </a:p>
         </p:txBody>
       </p:sp>
@@ -8320,6 +8416,7 @@
           <a:lstStyle/>
           <a:p>
             <a:pPr algn="ctr"/>
+            <a:endParaRPr/>
           </a:p>
         </p:txBody>
       </p:sp>
@@ -8465,6 +8562,7 @@
           <a:lstStyle/>
           <a:p>
             <a:pPr algn="ctr"/>
+            <a:endParaRPr/>
           </a:p>
         </p:txBody>
       </p:sp>
@@ -8610,6 +8708,7 @@
           <a:lstStyle/>
           <a:p>
             <a:pPr algn="ctr"/>
+            <a:endParaRPr/>
           </a:p>
         </p:txBody>
       </p:sp>
@@ -8826,7 +8925,7 @@
 </file>
 
 <file path=ppt/slides/slide5.xml><?xml version="1.0" encoding="utf-8"?>
-<p:sld xmlns:a="http://schemas.openxmlformats.org/drawingml/2006/main" xmlns:p="http://schemas.openxmlformats.org/presentationml/2006/main" xmlns:r="http://schemas.openxmlformats.org/officeDocument/2006/relationships">
+<p:sld xmlns:a="http://schemas.openxmlformats.org/drawingml/2006/main" xmlns:r="http://schemas.openxmlformats.org/officeDocument/2006/relationships" xmlns:p="http://schemas.openxmlformats.org/presentationml/2006/main">
   <p:cSld>
     <p:bg>
       <p:bgPr>
@@ -8842,7 +8941,14 @@
         <p:cNvGrpSpPr/>
         <p:nvPr/>
       </p:nvGrpSpPr>
-      <p:grpSpPr/>
+      <p:grpSpPr>
+        <a:xfrm>
+          <a:off x="0" y="0"/>
+          <a:ext cx="0" cy="0"/>
+          <a:chOff x="0" y="0"/>
+          <a:chExt cx="0" cy="0"/>
+        </a:xfrm>
+      </p:grpSpPr>
       <p:sp>
         <p:nvSpPr>
           <p:cNvPr id="2" name="Rectangle 1"/>
@@ -8883,6 +8989,7 @@
           <a:lstStyle/>
           <a:p>
             <a:pPr algn="ctr"/>
+            <a:endParaRPr/>
           </a:p>
         </p:txBody>
       </p:sp>
@@ -8960,6 +9067,7 @@
           <a:lstStyle/>
           <a:p>
             <a:pPr algn="ctr"/>
+            <a:endParaRPr/>
           </a:p>
         </p:txBody>
       </p:sp>
@@ -9039,6 +9147,7 @@
           <a:lstStyle/>
           <a:p>
             <a:pPr algn="ctr"/>
+            <a:endParaRPr/>
           </a:p>
         </p:txBody>
       </p:sp>
@@ -9082,6 +9191,7 @@
           <a:lstStyle/>
           <a:p>
             <a:pPr algn="ctr"/>
+            <a:endParaRPr/>
           </a:p>
         </p:txBody>
       </p:sp>
@@ -9229,6 +9339,7 @@
           <a:lstStyle/>
           <a:p>
             <a:pPr algn="ctr"/>
+            <a:endParaRPr/>
           </a:p>
         </p:txBody>
       </p:sp>
@@ -9272,6 +9383,7 @@
           <a:lstStyle/>
           <a:p>
             <a:pPr algn="ctr"/>
+            <a:endParaRPr/>
           </a:p>
         </p:txBody>
       </p:sp>
@@ -9419,6 +9531,7 @@
           <a:lstStyle/>
           <a:p>
             <a:pPr algn="ctr"/>
+            <a:endParaRPr/>
           </a:p>
         </p:txBody>
       </p:sp>
@@ -9462,6 +9575,7 @@
           <a:lstStyle/>
           <a:p>
             <a:pPr algn="ctr"/>
+            <a:endParaRPr/>
           </a:p>
         </p:txBody>
       </p:sp>
@@ -9609,6 +9723,7 @@
           <a:lstStyle/>
           <a:p>
             <a:pPr algn="ctr"/>
+            <a:endParaRPr/>
           </a:p>
         </p:txBody>
       </p:sp>
@@ -9652,6 +9767,7 @@
           <a:lstStyle/>
           <a:p>
             <a:pPr algn="ctr"/>
+            <a:endParaRPr/>
           </a:p>
         </p:txBody>
       </p:sp>
@@ -9799,6 +9915,7 @@
           <a:lstStyle/>
           <a:p>
             <a:pPr algn="ctr"/>
+            <a:endParaRPr/>
           </a:p>
         </p:txBody>
       </p:sp>
@@ -9842,6 +9959,7 @@
           <a:lstStyle/>
           <a:p>
             <a:pPr algn="ctr"/>
+            <a:endParaRPr/>
           </a:p>
         </p:txBody>
       </p:sp>
@@ -9989,6 +10107,7 @@
           <a:lstStyle/>
           <a:p>
             <a:pPr algn="ctr"/>
+            <a:endParaRPr/>
           </a:p>
         </p:txBody>
       </p:sp>
@@ -10032,6 +10151,7 @@
           <a:lstStyle/>
           <a:p>
             <a:pPr algn="ctr"/>
+            <a:endParaRPr/>
           </a:p>
         </p:txBody>
       </p:sp>
@@ -10179,6 +10299,7 @@
           <a:lstStyle/>
           <a:p>
             <a:pPr algn="ctr"/>
+            <a:endParaRPr/>
           </a:p>
         </p:txBody>
       </p:sp>
@@ -10222,6 +10343,7 @@
           <a:lstStyle/>
           <a:p>
             <a:pPr algn="ctr"/>
+            <a:endParaRPr/>
           </a:p>
         </p:txBody>
       </p:sp>
@@ -10369,6 +10491,7 @@
           <a:lstStyle/>
           <a:p>
             <a:pPr algn="ctr"/>
+            <a:endParaRPr/>
           </a:p>
         </p:txBody>
       </p:sp>
@@ -10412,6 +10535,7 @@
           <a:lstStyle/>
           <a:p>
             <a:pPr algn="ctr"/>
+            <a:endParaRPr/>
           </a:p>
         </p:txBody>
       </p:sp>
@@ -10526,7 +10650,7 @@
 </file>
 
 <file path=ppt/slides/slide6.xml><?xml version="1.0" encoding="utf-8"?>
-<p:sld xmlns:a="http://schemas.openxmlformats.org/drawingml/2006/main" xmlns:p="http://schemas.openxmlformats.org/presentationml/2006/main" xmlns:r="http://schemas.openxmlformats.org/officeDocument/2006/relationships">
+<p:sld xmlns:a="http://schemas.openxmlformats.org/drawingml/2006/main" xmlns:r="http://schemas.openxmlformats.org/officeDocument/2006/relationships" xmlns:p="http://schemas.openxmlformats.org/presentationml/2006/main">
   <p:cSld>
     <p:bg>
       <p:bgPr>
@@ -10542,7 +10666,14 @@
         <p:cNvGrpSpPr/>
         <p:nvPr/>
       </p:nvGrpSpPr>
-      <p:grpSpPr/>
+      <p:grpSpPr>
+        <a:xfrm>
+          <a:off x="0" y="0"/>
+          <a:ext cx="0" cy="0"/>
+          <a:chOff x="0" y="0"/>
+          <a:chExt cx="0" cy="0"/>
+        </a:xfrm>
+      </p:grpSpPr>
       <p:sp>
         <p:nvSpPr>
           <p:cNvPr id="2" name="Rectangle 1"/>
@@ -10583,6 +10714,7 @@
           <a:lstStyle/>
           <a:p>
             <a:pPr algn="ctr"/>
+            <a:endParaRPr/>
           </a:p>
         </p:txBody>
       </p:sp>
@@ -10660,6 +10792,7 @@
           <a:lstStyle/>
           <a:p>
             <a:pPr algn="ctr"/>
+            <a:endParaRPr/>
           </a:p>
         </p:txBody>
       </p:sp>
@@ -10737,6 +10870,7 @@
           <a:lstStyle/>
           <a:p>
             <a:pPr algn="ctr"/>
+            <a:endParaRPr/>
           </a:p>
         </p:txBody>
       </p:sp>
@@ -10984,6 +11118,7 @@
           <a:lstStyle/>
           <a:p>
             <a:pPr algn="ctr"/>
+            <a:endParaRPr/>
           </a:p>
         </p:txBody>
       </p:sp>
@@ -11231,6 +11366,7 @@
           <a:lstStyle/>
           <a:p>
             <a:pPr algn="ctr"/>
+            <a:endParaRPr/>
           </a:p>
         </p:txBody>
       </p:sp>
@@ -11478,6 +11614,7 @@
           <a:lstStyle/>
           <a:p>
             <a:pPr algn="ctr"/>
+            <a:endParaRPr/>
           </a:p>
         </p:txBody>
       </p:sp>
@@ -11725,6 +11862,7 @@
           <a:lstStyle/>
           <a:p>
             <a:pPr algn="ctr"/>
+            <a:endParaRPr/>
           </a:p>
         </p:txBody>
       </p:sp>
@@ -11972,6 +12110,7 @@
           <a:lstStyle/>
           <a:p>
             <a:pPr algn="ctr"/>
+            <a:endParaRPr/>
           </a:p>
         </p:txBody>
       </p:sp>
@@ -12256,7 +12395,7 @@
 </file>
 
 <file path=ppt/slides/slide7.xml><?xml version="1.0" encoding="utf-8"?>
-<p:sld xmlns:a="http://schemas.openxmlformats.org/drawingml/2006/main" xmlns:p="http://schemas.openxmlformats.org/presentationml/2006/main" xmlns:r="http://schemas.openxmlformats.org/officeDocument/2006/relationships">
+<p:sld xmlns:a="http://schemas.openxmlformats.org/drawingml/2006/main" xmlns:r="http://schemas.openxmlformats.org/officeDocument/2006/relationships" xmlns:p="http://schemas.openxmlformats.org/presentationml/2006/main">
   <p:cSld>
     <p:bg>
       <p:bgPr>
@@ -12272,7 +12411,14 @@
         <p:cNvGrpSpPr/>
         <p:nvPr/>
       </p:nvGrpSpPr>
-      <p:grpSpPr/>
+      <p:grpSpPr>
+        <a:xfrm>
+          <a:off x="0" y="0"/>
+          <a:ext cx="0" cy="0"/>
+          <a:chOff x="0" y="0"/>
+          <a:chExt cx="0" cy="0"/>
+        </a:xfrm>
+      </p:grpSpPr>
       <p:sp>
         <p:nvSpPr>
           <p:cNvPr id="2" name="Rectangle 1"/>
@@ -12313,6 +12459,7 @@
           <a:lstStyle/>
           <a:p>
             <a:pPr algn="ctr"/>
+            <a:endParaRPr/>
           </a:p>
         </p:txBody>
       </p:sp>
@@ -12390,6 +12537,7 @@
           <a:lstStyle/>
           <a:p>
             <a:pPr algn="ctr"/>
+            <a:endParaRPr/>
           </a:p>
         </p:txBody>
       </p:sp>
@@ -12469,6 +12617,7 @@
           <a:lstStyle/>
           <a:p>
             <a:pPr algn="ctr"/>
+            <a:endParaRPr/>
           </a:p>
         </p:txBody>
       </p:sp>
@@ -12617,6 +12766,7 @@
           <a:lstStyle/>
           <a:p>
             <a:pPr algn="ctr"/>
+            <a:endParaRPr/>
           </a:p>
         </p:txBody>
       </p:sp>
@@ -12765,6 +12915,7 @@
           <a:lstStyle/>
           <a:p>
             <a:pPr algn="ctr"/>
+            <a:endParaRPr/>
           </a:p>
         </p:txBody>
       </p:sp>
@@ -12777,7 +12928,7 @@
         <p:spPr>
           <a:xfrm>
             <a:off x="502920" y="5029200"/>
-            <a:ext cx="11155680" cy="411480"/>
+            <a:ext cx="11155680" cy="307777"/>
           </a:xfrm>
           <a:prstGeom prst="rect">
             <a:avLst/>
@@ -12792,12 +12943,12 @@
           <a:p>
             <a:pPr algn="ctr"/>
             <a:r>
-              <a:rPr sz="1400" b="1">
+              <a:rPr sz="1400" b="1" dirty="0">
                 <a:solidFill>
                   <a:srgbClr val="10B981"/>
                 </a:solidFill>
               </a:rPr>
-              <a:t>⚡  ~266 Watts saved per blocked request   |   AMD Infinity Fabric sleep-state active 95% of runtime</a:t>
+              <a:t> ~266 Watts saved per blocked request   |   AMD Infinity Fabric sleep-state active 95% of runtime</a:t>
             </a:r>
           </a:p>
         </p:txBody>
@@ -13015,7 +13166,7 @@
 </file>
 
 <file path=ppt/slides/slide8.xml><?xml version="1.0" encoding="utf-8"?>
-<p:sld xmlns:a="http://schemas.openxmlformats.org/drawingml/2006/main" xmlns:p="http://schemas.openxmlformats.org/presentationml/2006/main" xmlns:r="http://schemas.openxmlformats.org/officeDocument/2006/relationships">
+<p:sld xmlns:a="http://schemas.openxmlformats.org/drawingml/2006/main" xmlns:r="http://schemas.openxmlformats.org/officeDocument/2006/relationships" xmlns:p="http://schemas.openxmlformats.org/presentationml/2006/main">
   <p:cSld>
     <p:bg>
       <p:bgPr>
@@ -13031,7 +13182,14 @@
         <p:cNvGrpSpPr/>
         <p:nvPr/>
       </p:nvGrpSpPr>
-      <p:grpSpPr/>
+      <p:grpSpPr>
+        <a:xfrm>
+          <a:off x="0" y="0"/>
+          <a:ext cx="0" cy="0"/>
+          <a:chOff x="0" y="0"/>
+          <a:chExt cx="0" cy="0"/>
+        </a:xfrm>
+      </p:grpSpPr>
       <p:sp>
         <p:nvSpPr>
           <p:cNvPr id="2" name="Rectangle 1"/>
@@ -13072,6 +13230,7 @@
           <a:lstStyle/>
           <a:p>
             <a:pPr algn="ctr"/>
+            <a:endParaRPr/>
           </a:p>
         </p:txBody>
       </p:sp>
@@ -13149,6 +13308,7 @@
           <a:lstStyle/>
           <a:p>
             <a:pPr algn="ctr"/>
+            <a:endParaRPr/>
           </a:p>
         </p:txBody>
       </p:sp>
@@ -13192,6 +13352,7 @@
           <a:lstStyle/>
           <a:p>
             <a:pPr algn="ctr"/>
+            <a:endParaRPr/>
           </a:p>
         </p:txBody>
       </p:sp>
@@ -13371,6 +13532,7 @@
           <a:lstStyle/>
           <a:p>
             <a:pPr algn="ctr"/>
+            <a:endParaRPr/>
           </a:p>
         </p:txBody>
       </p:sp>
@@ -13550,6 +13712,7 @@
           <a:lstStyle/>
           <a:p>
             <a:pPr algn="ctr"/>
+            <a:endParaRPr/>
           </a:p>
         </p:txBody>
       </p:sp>
@@ -13729,6 +13892,7 @@
           <a:lstStyle/>
           <a:p>
             <a:pPr algn="ctr"/>
+            <a:endParaRPr/>
           </a:p>
         </p:txBody>
       </p:sp>
@@ -13908,6 +14072,7 @@
           <a:lstStyle/>
           <a:p>
             <a:pPr algn="ctr"/>
+            <a:endParaRPr/>
           </a:p>
         </p:txBody>
       </p:sp>
@@ -14087,6 +14252,7 @@
           <a:lstStyle/>
           <a:p>
             <a:pPr algn="ctr"/>
+            <a:endParaRPr/>
           </a:p>
         </p:txBody>
       </p:sp>
@@ -14266,6 +14432,7 @@
           <a:lstStyle/>
           <a:p>
             <a:pPr algn="ctr"/>
+            <a:endParaRPr/>
           </a:p>
         </p:txBody>
       </p:sp>
@@ -14445,6 +14612,7 @@
           <a:lstStyle/>
           <a:p>
             <a:pPr algn="ctr"/>
+            <a:endParaRPr/>
           </a:p>
         </p:txBody>
       </p:sp>
@@ -14624,6 +14792,7 @@
           <a:lstStyle/>
           <a:p>
             <a:pPr algn="ctr"/>
+            <a:endParaRPr/>
           </a:p>
         </p:txBody>
       </p:sp>
@@ -14803,6 +14972,7 @@
           <a:lstStyle/>
           <a:p>
             <a:pPr algn="ctr"/>
+            <a:endParaRPr/>
           </a:p>
         </p:txBody>
       </p:sp>
@@ -14982,6 +15152,7 @@
           <a:lstStyle/>
           <a:p>
             <a:pPr algn="ctr"/>
+            <a:endParaRPr/>
           </a:p>
         </p:txBody>
       </p:sp>
@@ -15164,7 +15335,7 @@
 </file>
 
 <file path=ppt/slides/slide9.xml><?xml version="1.0" encoding="utf-8"?>
-<p:sld xmlns:a="http://schemas.openxmlformats.org/drawingml/2006/main" xmlns:p="http://schemas.openxmlformats.org/presentationml/2006/main" xmlns:r="http://schemas.openxmlformats.org/officeDocument/2006/relationships">
+<p:sld xmlns:a="http://schemas.openxmlformats.org/drawingml/2006/main" xmlns:r="http://schemas.openxmlformats.org/officeDocument/2006/relationships" xmlns:p="http://schemas.openxmlformats.org/presentationml/2006/main">
   <p:cSld>
     <p:bg>
       <p:bgPr>
@@ -15180,7 +15351,14 @@
         <p:cNvGrpSpPr/>
         <p:nvPr/>
       </p:nvGrpSpPr>
-      <p:grpSpPr/>
+      <p:grpSpPr>
+        <a:xfrm>
+          <a:off x="0" y="0"/>
+          <a:ext cx="0" cy="0"/>
+          <a:chOff x="0" y="0"/>
+          <a:chExt cx="0" cy="0"/>
+        </a:xfrm>
+      </p:grpSpPr>
       <p:sp>
         <p:nvSpPr>
           <p:cNvPr id="2" name="Rectangle 1"/>
@@ -15221,6 +15399,7 @@
           <a:lstStyle/>
           <a:p>
             <a:pPr algn="ctr"/>
+            <a:endParaRPr/>
           </a:p>
         </p:txBody>
       </p:sp>
@@ -15298,6 +15477,7 @@
           <a:lstStyle/>
           <a:p>
             <a:pPr algn="ctr"/>
+            <a:endParaRPr/>
           </a:p>
         </p:txBody>
       </p:sp>
@@ -15615,6 +15795,7 @@
           <a:lstStyle/>
           <a:p>
             <a:pPr algn="ctr"/>
+            <a:endParaRPr/>
           </a:p>
         </p:txBody>
       </p:sp>
@@ -15658,6 +15839,7 @@
           <a:lstStyle/>
           <a:p>
             <a:pPr algn="ctr"/>
+            <a:endParaRPr/>
           </a:p>
         </p:txBody>
       </p:sp>
@@ -15820,14 +16002,7 @@
           <a:lstStyle/>
           <a:p>
             <a:pPr algn="l"/>
-            <a:r>
-              <a:rPr sz="1000" b="0">
-                <a:solidFill>
-                  <a:srgbClr val="FFFFFF"/>
-                </a:solidFill>
-              </a:rPr>
-              <a:t/>
-            </a:r>
+            <a:endParaRPr/>
           </a:p>
         </p:txBody>
       </p:sp>
@@ -15888,14 +16063,7 @@
           <a:lstStyle/>
           <a:p>
             <a:pPr algn="l"/>
-            <a:r>
-              <a:rPr sz="1000" b="0">
-                <a:solidFill>
-                  <a:srgbClr val="FFFFFF"/>
-                </a:solidFill>
-              </a:rPr>
-              <a:t/>
-            </a:r>
+            <a:endParaRPr/>
           </a:p>
         </p:txBody>
       </p:sp>

</xml_diff>